<commit_message>
restructure ppt and readme
</commit_message>
<xml_diff>
--- a/PPTs/Hardware_CAD_Midterm_2026.pptx
+++ b/PPTs/Hardware_CAD_Midterm_2026.pptx
@@ -18,6 +18,7 @@
     <p:sldId id="263" r:id="rId13"/>
     <p:sldId id="264" r:id="rId20"/>
     <p:sldId id="265" r:id="rId21"/>
+    <p:sldId id="266" r:id="rId22"/>
   </p:sldIdLst>
   <p:sldSz cx="18288000" cy="10287000"/>
   <p:notesSz cx="6858000" cy="9144000"/>
@@ -5268,6 +5269,416 @@
       <p:sp>
         <p:nvSpPr>
           <p:cNvPr id="23" name="TextBox 22"/>
+          <p:cNvSpPr txBox="1"/>
+          <p:nvPr/>
+        </p:nvSpPr>
+        <p:spPr>
+          <a:xfrm>
+            <a:off x="640080" y="9765792"/>
+            <a:ext cx="9144000" cy="228600"/>
+          </a:xfrm>
+          <a:prstGeom prst="rect">
+            <a:avLst/>
+          </a:prstGeom>
+          <a:noFill/>
+        </p:spPr>
+        <p:txBody>
+          <a:bodyPr wrap="square" lIns="27432" rIns="27432" tIns="27432" bIns="27432" anchor="t">
+            <a:spAutoFit/>
+          </a:bodyPr>
+          <a:lstStyle/>
+          <a:p>
+            <a:pPr algn="l"/>
+            <a:r>
+              <a:rPr sz="1100" b="0">
+                <a:solidFill>
+                  <a:srgbClr val="646E7A"/>
+                </a:solidFill>
+                <a:latin typeface="Poppins"/>
+              </a:rPr>
+              <a:t>IIT Delhi  ·  ELD411  ·  Mid-Term Review 2026</a:t>
+            </a:r>
+          </a:p>
+        </p:txBody>
+      </p:sp>
+    </p:spTree>
+  </p:cSld>
+  <p:clrMapOvr>
+    <a:masterClrMapping/>
+  </p:clrMapOvr>
+</p:sld>
+</file>
+
+<file path=ppt/slides/slide11.xml><?xml version="1.0" encoding="utf-8"?>
+<p:sld xmlns:a="http://schemas.openxmlformats.org/drawingml/2006/main" xmlns:p="http://schemas.openxmlformats.org/presentationml/2006/main" xmlns:r="http://schemas.openxmlformats.org/officeDocument/2006/relationships">
+  <p:cSld>
+    <p:bg>
+      <p:bgPr>
+        <a:solidFill>
+          <a:srgbClr val="F0F7FF"/>
+        </a:solidFill>
+        <a:effectLst/>
+      </p:bgPr>
+    </p:bg>
+    <p:spTree>
+      <p:nvGrpSpPr>
+        <p:cNvPr id="1" name=""/>
+        <p:cNvGrpSpPr/>
+        <p:nvPr/>
+      </p:nvGrpSpPr>
+      <p:grpSpPr/>
+      <p:sp>
+        <p:nvSpPr>
+          <p:cNvPr id="2" name="TextBox 1"/>
+          <p:cNvSpPr txBox="1"/>
+          <p:nvPr/>
+        </p:nvSpPr>
+        <p:spPr>
+          <a:xfrm>
+            <a:off x="640080" y="292608"/>
+            <a:ext cx="10972800" cy="292608"/>
+          </a:xfrm>
+          <a:prstGeom prst="rect">
+            <a:avLst/>
+          </a:prstGeom>
+          <a:noFill/>
+        </p:spPr>
+        <p:txBody>
+          <a:bodyPr wrap="square" lIns="27432" rIns="27432" tIns="27432" bIns="27432" anchor="t">
+            <a:spAutoFit/>
+          </a:bodyPr>
+          <a:lstStyle/>
+          <a:p>
+            <a:pPr algn="l"/>
+            <a:r>
+              <a:rPr sz="1300" b="1">
+                <a:solidFill>
+                  <a:srgbClr val="2BA7A0"/>
+                </a:solidFill>
+                <a:latin typeface="Poppins"/>
+              </a:rPr>
+              <a:t>VALIDATION</a:t>
+            </a:r>
+          </a:p>
+        </p:txBody>
+      </p:sp>
+      <p:sp>
+        <p:nvSpPr>
+          <p:cNvPr id="3" name="TextBox 2"/>
+          <p:cNvSpPr txBox="1"/>
+          <p:nvPr/>
+        </p:nvSpPr>
+        <p:spPr>
+          <a:xfrm>
+            <a:off x="640080" y="621792"/>
+            <a:ext cx="15087600" cy="566928"/>
+          </a:xfrm>
+          <a:prstGeom prst="rect">
+            <a:avLst/>
+          </a:prstGeom>
+          <a:noFill/>
+        </p:spPr>
+        <p:txBody>
+          <a:bodyPr wrap="square" lIns="27432" rIns="27432" tIns="27432" bIns="27432" anchor="t">
+            <a:spAutoFit/>
+          </a:bodyPr>
+          <a:lstStyle/>
+          <a:p>
+            <a:pPr algn="l"/>
+            <a:r>
+              <a:rPr sz="3000" b="1">
+                <a:solidFill>
+                  <a:srgbClr val="180E66"/>
+                </a:solidFill>
+                <a:latin typeface="Poppins"/>
+              </a:rPr>
+              <a:t>Simulation Recording — Gazebo</a:t>
+            </a:r>
+          </a:p>
+        </p:txBody>
+      </p:sp>
+      <p:sp>
+        <p:nvSpPr>
+          <p:cNvPr id="4" name="Rectangle 3"/>
+          <p:cNvSpPr/>
+          <p:nvPr/>
+        </p:nvSpPr>
+        <p:spPr>
+          <a:xfrm>
+            <a:off x="640080" y="1298448"/>
+            <a:ext cx="17007840" cy="13716"/>
+          </a:xfrm>
+          <a:prstGeom prst="rect">
+            <a:avLst/>
+          </a:prstGeom>
+          <a:solidFill>
+            <a:srgbClr val="D5DBE8"/>
+          </a:solidFill>
+          <a:ln>
+            <a:noFill/>
+          </a:ln>
+        </p:spPr>
+        <p:style>
+          <a:lnRef idx="1">
+            <a:schemeClr val="accent1"/>
+          </a:lnRef>
+          <a:fillRef idx="3">
+            <a:schemeClr val="accent1"/>
+          </a:fillRef>
+          <a:effectRef idx="2">
+            <a:schemeClr val="accent1"/>
+          </a:effectRef>
+          <a:fontRef idx="minor">
+            <a:schemeClr val="lt1"/>
+          </a:fontRef>
+        </p:style>
+        <p:txBody>
+          <a:bodyPr rtlCol="0" anchor="ctr"/>
+          <a:lstStyle/>
+          <a:p>
+            <a:pPr algn="ctr"/>
+          </a:p>
+        </p:txBody>
+      </p:sp>
+      <p:sp>
+        <p:nvSpPr>
+          <p:cNvPr id="5" name="TextBox 4"/>
+          <p:cNvSpPr txBox="1"/>
+          <p:nvPr/>
+        </p:nvSpPr>
+        <p:spPr>
+          <a:xfrm>
+            <a:off x="16916400" y="329184"/>
+            <a:ext cx="731520" cy="292608"/>
+          </a:xfrm>
+          <a:prstGeom prst="rect">
+            <a:avLst/>
+          </a:prstGeom>
+          <a:noFill/>
+        </p:spPr>
+        <p:txBody>
+          <a:bodyPr wrap="square" lIns="27432" rIns="27432" tIns="27432" bIns="27432" anchor="t">
+            <a:spAutoFit/>
+          </a:bodyPr>
+          <a:lstStyle/>
+          <a:p>
+            <a:pPr algn="r"/>
+            <a:r>
+              <a:rPr sz="1300" b="1">
+                <a:solidFill>
+                  <a:srgbClr val="646E7A"/>
+                </a:solidFill>
+                <a:latin typeface="Poppins"/>
+              </a:rPr>
+              <a:t>11</a:t>
+            </a:r>
+          </a:p>
+        </p:txBody>
+      </p:sp>
+      <p:sp>
+        <p:nvSpPr>
+          <p:cNvPr id="6" name="Rounded Rectangle 5"/>
+          <p:cNvSpPr/>
+          <p:nvPr/>
+        </p:nvSpPr>
+        <p:spPr>
+          <a:xfrm>
+            <a:off x="640080" y="1600200"/>
+            <a:ext cx="16642080" cy="7635240"/>
+          </a:xfrm>
+          <a:prstGeom prst="roundRect">
+            <a:avLst/>
+          </a:prstGeom>
+          <a:solidFill>
+            <a:srgbClr val="0F172A"/>
+          </a:solidFill>
+          <a:ln w="15875">
+            <a:solidFill>
+              <a:srgbClr val="0F172A"/>
+            </a:solidFill>
+          </a:ln>
+        </p:spPr>
+        <p:style>
+          <a:lnRef idx="1">
+            <a:schemeClr val="accent1"/>
+          </a:lnRef>
+          <a:fillRef idx="3">
+            <a:schemeClr val="accent1"/>
+          </a:fillRef>
+          <a:effectRef idx="2">
+            <a:schemeClr val="accent1"/>
+          </a:effectRef>
+          <a:fontRef idx="minor">
+            <a:schemeClr val="lt1"/>
+          </a:fontRef>
+        </p:style>
+        <p:txBody>
+          <a:bodyPr rtlCol="0" anchor="ctr"/>
+          <a:lstStyle/>
+          <a:p>
+            <a:pPr algn="ctr"/>
+          </a:p>
+        </p:txBody>
+      </p:sp>
+      <p:sp>
+        <p:nvSpPr>
+          <p:cNvPr id="7" name="Oval 6"/>
+          <p:cNvSpPr/>
+          <p:nvPr/>
+        </p:nvSpPr>
+        <p:spPr>
+          <a:xfrm>
+            <a:off x="8321040" y="4572000"/>
+            <a:ext cx="914400" cy="914400"/>
+          </a:xfrm>
+          <a:prstGeom prst="ellipse">
+            <a:avLst/>
+          </a:prstGeom>
+          <a:solidFill>
+            <a:srgbClr val="FFFFFF"/>
+          </a:solidFill>
+          <a:ln>
+            <a:noFill/>
+          </a:ln>
+        </p:spPr>
+        <p:style>
+          <a:lnRef idx="1">
+            <a:schemeClr val="accent1"/>
+          </a:lnRef>
+          <a:fillRef idx="3">
+            <a:schemeClr val="accent1"/>
+          </a:fillRef>
+          <a:effectRef idx="2">
+            <a:schemeClr val="accent1"/>
+          </a:effectRef>
+          <a:fontRef idx="minor">
+            <a:schemeClr val="lt1"/>
+          </a:fontRef>
+        </p:style>
+        <p:txBody>
+          <a:bodyPr rtlCol="0" anchor="ctr"/>
+          <a:lstStyle/>
+          <a:p>
+            <a:pPr algn="ctr"/>
+          </a:p>
+        </p:txBody>
+      </p:sp>
+      <p:sp>
+        <p:nvSpPr>
+          <p:cNvPr id="8" name="Isosceles Triangle 7"/>
+          <p:cNvSpPr/>
+          <p:nvPr/>
+        </p:nvSpPr>
+        <p:spPr>
+          <a:xfrm rot="5400000">
+            <a:off x="8613648" y="4773168"/>
+            <a:ext cx="384048" cy="512064"/>
+          </a:xfrm>
+          <a:prstGeom prst="triangle">
+            <a:avLst/>
+          </a:prstGeom>
+          <a:solidFill>
+            <a:srgbClr val="180E66"/>
+          </a:solidFill>
+          <a:ln>
+            <a:noFill/>
+          </a:ln>
+        </p:spPr>
+        <p:style>
+          <a:lnRef idx="1">
+            <a:schemeClr val="accent1"/>
+          </a:lnRef>
+          <a:fillRef idx="3">
+            <a:schemeClr val="accent1"/>
+          </a:fillRef>
+          <a:effectRef idx="2">
+            <a:schemeClr val="accent1"/>
+          </a:effectRef>
+          <a:fontRef idx="minor">
+            <a:schemeClr val="lt1"/>
+          </a:fontRef>
+        </p:style>
+        <p:txBody>
+          <a:bodyPr rtlCol="0" anchor="ctr"/>
+          <a:lstStyle/>
+          <a:p>
+            <a:pPr algn="ctr"/>
+          </a:p>
+        </p:txBody>
+      </p:sp>
+      <p:sp>
+        <p:nvSpPr>
+          <p:cNvPr id="9" name="TextBox 8"/>
+          <p:cNvSpPr txBox="1"/>
+          <p:nvPr/>
+        </p:nvSpPr>
+        <p:spPr>
+          <a:xfrm>
+            <a:off x="822960" y="5623560"/>
+            <a:ext cx="16459200" cy="320040"/>
+          </a:xfrm>
+          <a:prstGeom prst="rect">
+            <a:avLst/>
+          </a:prstGeom>
+          <a:noFill/>
+        </p:spPr>
+        <p:txBody>
+          <a:bodyPr wrap="square" lIns="27432" rIns="27432" tIns="27432" bIns="27432" anchor="t">
+            <a:spAutoFit/>
+          </a:bodyPr>
+          <a:lstStyle/>
+          <a:p>
+            <a:pPr algn="ctr"/>
+            <a:r>
+              <a:rPr sz="1500" b="1">
+                <a:solidFill>
+                  <a:srgbClr val="FFFFFF"/>
+                </a:solidFill>
+                <a:latin typeface="Poppins"/>
+              </a:rPr>
+              <a:t>DROP THE GAZEBO SIM RECORDING HERE</a:t>
+            </a:r>
+          </a:p>
+        </p:txBody>
+      </p:sp>
+      <p:sp>
+        <p:nvSpPr>
+          <p:cNvPr id="10" name="TextBox 9"/>
+          <p:cNvSpPr txBox="1"/>
+          <p:nvPr/>
+        </p:nvSpPr>
+        <p:spPr>
+          <a:xfrm>
+            <a:off x="822960" y="5989320"/>
+            <a:ext cx="16459200" cy="274320"/>
+          </a:xfrm>
+          <a:prstGeom prst="rect">
+            <a:avLst/>
+          </a:prstGeom>
+          <a:noFill/>
+        </p:spPr>
+        <p:txBody>
+          <a:bodyPr wrap="square" lIns="27432" rIns="27432" tIns="27432" bIns="27432" anchor="t">
+            <a:spAutoFit/>
+          </a:bodyPr>
+          <a:lstStyle/>
+          <a:p>
+            <a:pPr algn="ctr"/>
+            <a:r>
+              <a:rPr sz="1100" b="0">
+                <a:solidFill>
+                  <a:srgbClr val="9AA5C9"/>
+                </a:solidFill>
+                <a:latin typeface="Poppins"/>
+              </a:rPr>
+              <a:t>Arm + dish carousel, pick-and-place cycle</a:t>
+            </a:r>
+          </a:p>
+        </p:txBody>
+      </p:sp>
+      <p:sp>
+        <p:nvSpPr>
+          <p:cNvPr id="11" name="TextBox 10"/>
           <p:cNvSpPr txBox="1"/>
           <p:nvPr/>
         </p:nvSpPr>

</xml_diff>